<commit_message>
Slide AI su plugin, PDF da guardare
</commit_message>
<xml_diff>
--- a/Sicurezza Parte 1, Presentazione.pptx
+++ b/Sicurezza Parte 1, Presentazione.pptx
@@ -120,39 +120,39 @@
   <p:extLst>
     <p:ext uri="{521415D9-36F7-43E2-AB2F-B90AF26B5E84}">
       <p14:sectionLst xmlns:p14="http://schemas.microsoft.com/office/powerpoint/2010/main">
-        <p14:section name="Apertura" id="{9c9110cd-1833-69af-cf4f-a7d03176b59a}">
+        <p14:section name="Apertura" id="{ed09f2b7-abad-bfa7-be3e-b44fa05742c0}">
           <p14:sldIdLst>
             <p14:sldId id="256"/>
             <p14:sldId id="257"/>
           </p14:sldIdLst>
         </p14:section>
-        <p14:section name="Perché" id="{5dbec7d1-80c1-ab5e-7ba2-ffd4066f7d3a}">
+        <p14:section name="Perché" id="{25bd3fd8-0df8-74f0-2666-d3ec19711281}">
           <p14:sldIdLst>
             <p14:sldId id="258"/>
             <p14:sldId id="259"/>
             <p14:sldId id="260"/>
           </p14:sldIdLst>
         </p14:section>
-        <p14:section name="Le basi" id="{ceb036d1-138d-4572-5d21-3fee7f30c6bf}">
+        <p14:section name="Le basi" id="{a7e1c1b4-1301-1c66-aeb5-a34c96541ac7}">
           <p14:sldIdLst>
             <p14:sldId id="261"/>
             <p14:sldId id="262"/>
             <p14:sldId id="263"/>
           </p14:sldIdLst>
         </p14:section>
-        <p14:section name="Il materiale" id="{1178f9c2-07c1-0843-be44-debe44ec184c}">
+        <p14:section name="Il materiale" id="{db38f948-beb9-5aea-58ee-e7afa7528b55}">
           <p14:sldIdLst>
             <p14:sldId id="264"/>
             <p14:sldId id="265"/>
           </p14:sldIdLst>
         </p14:section>
-        <p14:section name="Adesso" id="{fd947f3e-1a42-3075-de88-39516fda0638}">
+        <p14:section name="Adesso" id="{1ff590cc-96b7-4f59-4363-777fc8e17451}">
           <p14:sldIdLst>
             <p14:sldId id="266"/>
             <p14:sldId id="267"/>
           </p14:sldIdLst>
         </p14:section>
-        <p14:section name="Chiusura" id="{89c719bd-50a9-a4c8-5947-43c4830d451f}">
+        <p14:section name="Chiusura" id="{eac31c15-6881-9064-c80a-10f4242f96b1}">
           <p14:sldIdLst>
             <p14:sldId id="268"/>
             <p14:sldId id="269"/>

</xml_diff>

<commit_message>
AI deck: esempio Real Estate OS
</commit_message>
<xml_diff>
--- a/Sicurezza Parte 1, Presentazione.pptx
+++ b/Sicurezza Parte 1, Presentazione.pptx
@@ -120,39 +120,39 @@
   <p:extLst>
     <p:ext uri="{521415D9-36F7-43E2-AB2F-B90AF26B5E84}">
       <p14:sectionLst xmlns:p14="http://schemas.microsoft.com/office/powerpoint/2010/main">
-        <p14:section name="Apertura" id="{ed09f2b7-abad-bfa7-be3e-b44fa05742c0}">
+        <p14:section name="Apertura" id="{f12504e4-d57b-e5f5-1365-cdb6ed9fb1fc}">
           <p14:sldIdLst>
             <p14:sldId id="256"/>
             <p14:sldId id="257"/>
           </p14:sldIdLst>
         </p14:section>
-        <p14:section name="Perché" id="{25bd3fd8-0df8-74f0-2666-d3ec19711281}">
+        <p14:section name="Perché" id="{69f08ec6-f183-b4ae-2f5c-0f898cbbd55f}">
           <p14:sldIdLst>
             <p14:sldId id="258"/>
             <p14:sldId id="259"/>
             <p14:sldId id="260"/>
           </p14:sldIdLst>
         </p14:section>
-        <p14:section name="Le basi" id="{a7e1c1b4-1301-1c66-aeb5-a34c96541ac7}">
+        <p14:section name="Le basi" id="{30f9c72e-3653-b79a-5df3-a1c9c7a1b27e}">
           <p14:sldIdLst>
             <p14:sldId id="261"/>
             <p14:sldId id="262"/>
             <p14:sldId id="263"/>
           </p14:sldIdLst>
         </p14:section>
-        <p14:section name="Il materiale" id="{db38f948-beb9-5aea-58ee-e7afa7528b55}">
+        <p14:section name="Il materiale" id="{cf9800df-a507-39c4-98b2-81b85e160ef3}">
           <p14:sldIdLst>
             <p14:sldId id="264"/>
             <p14:sldId id="265"/>
           </p14:sldIdLst>
         </p14:section>
-        <p14:section name="Adesso" id="{1ff590cc-96b7-4f59-4363-777fc8e17451}">
+        <p14:section name="Adesso" id="{bed46ea1-151a-f1ce-8eb2-498d1a9b1d77}">
           <p14:sldIdLst>
             <p14:sldId id="266"/>
             <p14:sldId id="267"/>
           </p14:sldIdLst>
         </p14:section>
-        <p14:section name="Chiusura" id="{eac31c15-6881-9064-c80a-10f4242f96b1}">
+        <p14:section name="Chiusura" id="{1a970801-55d8-c257-73d8-b059daf7837b}">
           <p14:sldIdLst>
             <p14:sldId id="268"/>
             <p14:sldId id="269"/>

</xml_diff>